<commit_message>
fix(defensa): corrige la presentacion y actualiza el banco de preguntas
La portada listaba cinco integrantes y una diapositiva repartia tiempos entre
cuatro, marcaba a una persona por debajo del minimo y dejaba escrito que un ex
integrante no aporto al trabajo real. Se elimina la diapositiva de recorrido, se
rehace la de participacion con los dos integrantes, y se renumeran los cuadros
de pagina, que son texto fijo.

El banco de preguntas arrastraba cuatro cifras anteriores a las correcciones: la
completitud, la cadena hacia adelante, las columnas de la matriz y el umbral de
trazabilidad. Se anade ademas la potencia del analisis por item junto a la del
juez, porque dar solo una de las dos deja la respuesta a medias.
</commit_message>
<xml_diff>
--- a/08_Defensa/presentacion.pptx
+++ b/08_Defensa/presentacion.pptx
@@ -6,7 +6,6 @@
   </p:sldMasterIdLst>
   <p:sldIdLst>
     <p:sldId id="256" r:id="rId2"/>
-    <p:sldId id="257" r:id="rId3"/>
     <p:sldId id="258" r:id="rId4"/>
     <p:sldId id="259" r:id="rId5"/>
     <p:sldId id="260" r:id="rId6"/>
@@ -1962,6 +1961,10 @@
           </a:solidFill>
           <a:ln/>
         </p:spPr>
+        <p:txBody>
+          <a:bodyPr/>
+          <a:p/>
+        </p:txBody>
       </p:sp>
       <p:sp>
         <p:nvSpPr>
@@ -2063,6 +2066,10 @@
             <a:prstDash val="solid"/>
           </a:ln>
         </p:spPr>
+        <p:txBody>
+          <a:bodyPr/>
+          <a:p/>
+        </p:txBody>
       </p:sp>
       <p:sp>
         <p:nvSpPr>
@@ -2178,7 +2185,7 @@
                 <a:ea typeface="Calibri" pitchFamily="34" charset="-122"/>
                 <a:cs typeface="Calibri" pitchFamily="34" charset="-120"/>
               </a:rPr>
-              <a:t>Sánchez Cornejo · Muñoz Quiñónez · Gilces Carranza · Mendoza Palma · Cedeño Ávila</a:t>
+              <a:t>Sánchez Cornejo, Gary Alberto · Muñoz Quiñónez, Yeranick Esther</a:t>
             </a:r>
             <a:endParaRPr lang="en-US" sz="1200" dirty="0"/>
           </a:p>
@@ -2335,6 +2342,10 @@
           </a:solidFill>
           <a:ln/>
         </p:spPr>
+        <p:txBody>
+          <a:bodyPr/>
+          <a:p/>
+        </p:txBody>
       </p:sp>
       <p:sp>
         <p:nvSpPr>
@@ -2433,6 +2444,10 @@
           </a:solidFill>
           <a:ln/>
         </p:spPr>
+        <p:txBody>
+          <a:bodyPr/>
+          <a:p/>
+        </p:txBody>
       </p:sp>
       <p:sp>
         <p:nvSpPr>
@@ -2492,6 +2507,10 @@
           </a:solidFill>
           <a:ln/>
         </p:spPr>
+        <p:txBody>
+          <a:bodyPr/>
+          <a:p/>
+        </p:txBody>
       </p:sp>
       <p:sp>
         <p:nvSpPr>
@@ -2551,6 +2570,10 @@
           </a:solidFill>
           <a:ln/>
         </p:spPr>
+        <p:txBody>
+          <a:bodyPr/>
+          <a:p/>
+        </p:txBody>
       </p:sp>
       <p:sp>
         <p:nvSpPr>
@@ -2612,6 +2635,10 @@
           </a:solidFill>
           <a:ln/>
         </p:spPr>
+        <p:txBody>
+          <a:bodyPr/>
+          <a:p/>
+        </p:txBody>
       </p:sp>
       <p:sp>
         <p:nvSpPr>
@@ -2724,7 +2751,7 @@
                 <a:ea typeface="Calibri" pitchFamily="34" charset="-122"/>
                 <a:cs typeface="Calibri" pitchFamily="34" charset="-120"/>
               </a:rPr>
-              <a:t>10</a:t>
+              <a:t>9</a:t>
             </a:r>
             <a:endParaRPr lang="en-US" sz="1000" dirty="0"/>
           </a:p>
@@ -2861,6 +2888,10 @@
           </a:solidFill>
           <a:ln/>
         </p:spPr>
+        <p:txBody>
+          <a:bodyPr/>
+          <a:p/>
+        </p:txBody>
       </p:sp>
       <p:sp>
         <p:nvSpPr>
@@ -2922,6 +2953,10 @@
           </a:solidFill>
           <a:ln/>
         </p:spPr>
+        <p:txBody>
+          <a:bodyPr/>
+          <a:p/>
+        </p:txBody>
       </p:sp>
       <p:sp>
         <p:nvSpPr>
@@ -2983,6 +3018,10 @@
           </a:solidFill>
           <a:ln/>
         </p:spPr>
+        <p:txBody>
+          <a:bodyPr/>
+          <a:p/>
+        </p:txBody>
       </p:sp>
       <p:sp>
         <p:nvSpPr>
@@ -3044,6 +3083,10 @@
           </a:solidFill>
           <a:ln/>
         </p:spPr>
+        <p:txBody>
+          <a:bodyPr/>
+          <a:p/>
+        </p:txBody>
       </p:sp>
       <p:sp>
         <p:nvSpPr>
@@ -3105,6 +3148,10 @@
           </a:solidFill>
           <a:ln/>
         </p:spPr>
+        <p:txBody>
+          <a:bodyPr/>
+          <a:p/>
+        </p:txBody>
       </p:sp>
       <p:sp>
         <p:nvSpPr>
@@ -3166,6 +3213,10 @@
           </a:solidFill>
           <a:ln/>
         </p:spPr>
+        <p:txBody>
+          <a:bodyPr/>
+          <a:p/>
+        </p:txBody>
       </p:sp>
       <p:sp>
         <p:nvSpPr>
@@ -3227,6 +3278,10 @@
           </a:solidFill>
           <a:ln/>
         </p:spPr>
+        <p:txBody>
+          <a:bodyPr/>
+          <a:p/>
+        </p:txBody>
       </p:sp>
       <p:sp>
         <p:nvSpPr>
@@ -3339,7 +3394,7 @@
                 <a:ea typeface="Calibri" pitchFamily="34" charset="-122"/>
                 <a:cs typeface="Calibri" pitchFamily="34" charset="-120"/>
               </a:rPr>
-              <a:t>11</a:t>
+              <a:t>10</a:t>
             </a:r>
             <a:endParaRPr lang="en-US" sz="1000" dirty="0"/>
           </a:p>
@@ -3410,7 +3465,7 @@
                 <a:ea typeface="Calibri" pitchFamily="34" charset="-122"/>
                 <a:cs typeface="Calibri" pitchFamily="34" charset="-120"/>
               </a:rPr>
-              <a:t>ANTES DEL SIMULACRO</a:t>
+              <a:t>PARTICIPACIÓN</a:t>
             </a:r>
             <a:endParaRPr lang="en-US" sz="1200" dirty="0"/>
           </a:p>
@@ -3449,7 +3504,7 @@
                 <a:ea typeface="Cambria" pitchFamily="34" charset="-122"/>
                 <a:cs typeface="Cambria" pitchFamily="34" charset="-120"/>
               </a:rPr>
-              <a:t>Reparto de tiempos — ajustar antes de la semana 16</a:t>
+              <a:t>Dos integrantes, veinticinco minutos repartidos</a:t>
             </a:r>
             <a:endParaRPr lang="en-US" sz="3200" dirty="0"/>
           </a:p>
@@ -3488,7 +3543,7 @@
                 <a:ea typeface="Calibri" pitchFamily="34" charset="-122"/>
                 <a:cs typeface="Calibri" pitchFamily="34" charset="-120"/>
               </a:rPr>
-              <a:t>Sánchez Cornejo, Gary</a:t>
+              <a:t>Sánchez Cornejo, Gary Alberto</a:t>
             </a:r>
             <a:endParaRPr lang="en-US" sz="1350" dirty="0"/>
           </a:p>
@@ -3515,6 +3570,10 @@
           </a:solidFill>
           <a:ln/>
         </p:spPr>
+        <p:txBody>
+          <a:bodyPr/>
+          <a:p/>
+        </p:txBody>
       </p:sp>
       <p:sp>
         <p:nvSpPr>
@@ -3537,6 +3596,10 @@
           </a:solidFill>
           <a:ln/>
         </p:spPr>
+        <p:txBody>
+          <a:bodyPr/>
+          <a:p/>
+        </p:txBody>
       </p:sp>
       <p:sp>
         <p:nvSpPr>
@@ -3571,7 +3634,7 @@
                 <a:ea typeface="Calibri" pitchFamily="34" charset="-122"/>
                 <a:cs typeface="Calibri" pitchFamily="34" charset="-120"/>
               </a:rPr>
-              <a:t>11 min</a:t>
+              <a:t>13 min</a:t>
             </a:r>
             <a:endParaRPr lang="en-US" sz="1300" dirty="0"/>
           </a:p>
@@ -3610,7 +3673,7 @@
                 <a:ea typeface="Calibri" pitchFamily="34" charset="-122"/>
                 <a:cs typeface="Calibri" pitchFamily="34" charset="-120"/>
               </a:rPr>
-              <a:t>Mendoza Palma, Allan</a:t>
+              <a:t>Muñoz Quiñónez, Yeranick Esther</a:t>
             </a:r>
             <a:endParaRPr lang="en-US" sz="1350" dirty="0"/>
           </a:p>
@@ -3637,6 +3700,10 @@
           </a:solidFill>
           <a:ln/>
         </p:spPr>
+        <p:txBody>
+          <a:bodyPr/>
+          <a:p/>
+        </p:txBody>
       </p:sp>
       <p:sp>
         <p:nvSpPr>
@@ -3647,7 +3714,7 @@
         <p:spPr>
           <a:xfrm>
             <a:off x="4023360" y="2478024"/>
-            <a:ext cx="2261062" cy="310896"/>
+            <a:ext cx="5739618" cy="310896"/>
           </a:xfrm>
           <a:prstGeom prst="roundRect">
             <a:avLst>
@@ -3659,6 +3726,10 @@
           </a:solidFill>
           <a:ln/>
         </p:spPr>
+        <p:txBody>
+          <a:bodyPr/>
+          <a:p/>
+        </p:txBody>
       </p:sp>
       <p:sp>
         <p:nvSpPr>
@@ -3693,251 +3764,7 @@
                 <a:ea typeface="Calibri" pitchFamily="34" charset="-122"/>
                 <a:cs typeface="Calibri" pitchFamily="34" charset="-120"/>
               </a:rPr>
-              <a:t>4 min</a:t>
-            </a:r>
-            <a:endParaRPr lang="en-US" sz="1300" dirty="0"/>
-          </a:p>
-        </p:txBody>
-      </p:sp>
-      <p:sp>
-        <p:nvSpPr>
-          <p:cNvPr id="12" name="Text 10"/>
-          <p:cNvSpPr txBox="1"/>
-          <p:nvPr/>
-        </p:nvSpPr>
-        <p:spPr>
-          <a:xfrm>
-            <a:off x="640080" y="3118104"/>
-            <a:ext cx="3200400" cy="457200"/>
-          </a:xfrm>
-          <a:prstGeom prst="rect">
-            <a:avLst/>
-          </a:prstGeom>
-          <a:noFill/>
-          <a:ln/>
-        </p:spPr>
-        <p:txBody>
-          <a:bodyPr wrap="square" lIns="0" tIns="0" rIns="0" bIns="0" rtlCol="0" anchor="ctr"/>
-          <a:lstStyle/>
-          <a:p>
-            <a:pPr indent="0" marL="0">
-              <a:buNone/>
-            </a:pPr>
-            <a:r>
-              <a:rPr lang="en-US" sz="1350" dirty="0">
-                <a:solidFill>
-                  <a:srgbClr val="1F2421"/>
-                </a:solidFill>
-                <a:latin typeface="Calibri" pitchFamily="34" charset="0"/>
-                <a:ea typeface="Calibri" pitchFamily="34" charset="-122"/>
-                <a:cs typeface="Calibri" pitchFamily="34" charset="-120"/>
-              </a:rPr>
-              <a:t>Cedeño Ávila, Winston</a:t>
-            </a:r>
-            <a:endParaRPr lang="en-US" sz="1350" dirty="0"/>
-          </a:p>
-        </p:txBody>
-      </p:sp>
-      <p:sp>
-        <p:nvSpPr>
-          <p:cNvPr id="13" name="Shape 11"/>
-          <p:cNvSpPr/>
-          <p:nvPr/>
-        </p:nvSpPr>
-        <p:spPr>
-          <a:xfrm>
-            <a:off x="4023360" y="3191256"/>
-            <a:ext cx="6217920" cy="310896"/>
-          </a:xfrm>
-          <a:prstGeom prst="roundRect">
-            <a:avLst>
-              <a:gd name="adj" fmla="val 11765"/>
-            </a:avLst>
-          </a:prstGeom>
-          <a:solidFill>
-            <a:srgbClr val="E4E9E6"/>
-          </a:solidFill>
-          <a:ln/>
-        </p:spPr>
-      </p:sp>
-      <p:sp>
-        <p:nvSpPr>
-          <p:cNvPr id="14" name="Shape 12"/>
-          <p:cNvSpPr/>
-          <p:nvPr/>
-        </p:nvSpPr>
-        <p:spPr>
-          <a:xfrm>
-            <a:off x="4023360" y="3191256"/>
-            <a:ext cx="2261062" cy="310896"/>
-          </a:xfrm>
-          <a:prstGeom prst="roundRect">
-            <a:avLst>
-              <a:gd name="adj" fmla="val 11765"/>
-            </a:avLst>
-          </a:prstGeom>
-          <a:solidFill>
-            <a:srgbClr val="1B4332"/>
-          </a:solidFill>
-          <a:ln/>
-        </p:spPr>
-      </p:sp>
-      <p:sp>
-        <p:nvSpPr>
-          <p:cNvPr id="15" name="Text 13"/>
-          <p:cNvSpPr txBox="1"/>
-          <p:nvPr/>
-        </p:nvSpPr>
-        <p:spPr>
-          <a:xfrm>
-            <a:off x="10378440" y="3118104"/>
-            <a:ext cx="914400" cy="457200"/>
-          </a:xfrm>
-          <a:prstGeom prst="rect">
-            <a:avLst/>
-          </a:prstGeom>
-          <a:noFill/>
-          <a:ln/>
-        </p:spPr>
-        <p:txBody>
-          <a:bodyPr wrap="square" lIns="0" tIns="0" rIns="0" bIns="0" rtlCol="0" anchor="ctr"/>
-          <a:lstStyle/>
-          <a:p>
-            <a:pPr indent="0" marL="0">
-              <a:buNone/>
-            </a:pPr>
-            <a:r>
-              <a:rPr lang="en-US" sz="1300" b="1" dirty="0">
-                <a:solidFill>
-                  <a:srgbClr val="1B4332"/>
-                </a:solidFill>
-                <a:latin typeface="Calibri" pitchFamily="34" charset="0"/>
-                <a:ea typeface="Calibri" pitchFamily="34" charset="-122"/>
-                <a:cs typeface="Calibri" pitchFamily="34" charset="-120"/>
-              </a:rPr>
-              <a:t>4 min</a:t>
-            </a:r>
-            <a:endParaRPr lang="en-US" sz="1300" dirty="0"/>
-          </a:p>
-        </p:txBody>
-      </p:sp>
-      <p:sp>
-        <p:nvSpPr>
-          <p:cNvPr id="16" name="Text 14"/>
-          <p:cNvSpPr txBox="1"/>
-          <p:nvPr/>
-        </p:nvSpPr>
-        <p:spPr>
-          <a:xfrm>
-            <a:off x="640080" y="3831336"/>
-            <a:ext cx="3200400" cy="457200"/>
-          </a:xfrm>
-          <a:prstGeom prst="rect">
-            <a:avLst/>
-          </a:prstGeom>
-          <a:noFill/>
-          <a:ln/>
-        </p:spPr>
-        <p:txBody>
-          <a:bodyPr wrap="square" lIns="0" tIns="0" rIns="0" bIns="0" rtlCol="0" anchor="ctr"/>
-          <a:lstStyle/>
-          <a:p>
-            <a:pPr indent="0" marL="0">
-              <a:buNone/>
-            </a:pPr>
-            <a:r>
-              <a:rPr lang="en-US" sz="1350" dirty="0">
-                <a:solidFill>
-                  <a:srgbClr val="1F2421"/>
-                </a:solidFill>
-                <a:latin typeface="Calibri" pitchFamily="34" charset="0"/>
-                <a:ea typeface="Calibri" pitchFamily="34" charset="-122"/>
-                <a:cs typeface="Calibri" pitchFamily="34" charset="-120"/>
-              </a:rPr>
-              <a:t>Muñoz Quiñónez, Yeranick</a:t>
-            </a:r>
-            <a:endParaRPr lang="en-US" sz="1350" dirty="0"/>
-          </a:p>
-        </p:txBody>
-      </p:sp>
-      <p:sp>
-        <p:nvSpPr>
-          <p:cNvPr id="17" name="Shape 15"/>
-          <p:cNvSpPr/>
-          <p:nvPr/>
-        </p:nvSpPr>
-        <p:spPr>
-          <a:xfrm>
-            <a:off x="4023360" y="3904488"/>
-            <a:ext cx="6217920" cy="310896"/>
-          </a:xfrm>
-          <a:prstGeom prst="roundRect">
-            <a:avLst>
-              <a:gd name="adj" fmla="val 11765"/>
-            </a:avLst>
-          </a:prstGeom>
-          <a:solidFill>
-            <a:srgbClr val="E4E9E6"/>
-          </a:solidFill>
-          <a:ln/>
-        </p:spPr>
-      </p:sp>
-      <p:sp>
-        <p:nvSpPr>
-          <p:cNvPr id="18" name="Shape 16"/>
-          <p:cNvSpPr/>
-          <p:nvPr/>
-        </p:nvSpPr>
-        <p:spPr>
-          <a:xfrm>
-            <a:off x="4023360" y="3904488"/>
-            <a:ext cx="1695796" cy="310896"/>
-          </a:xfrm>
-          <a:prstGeom prst="roundRect">
-            <a:avLst>
-              <a:gd name="adj" fmla="val 11765"/>
-            </a:avLst>
-          </a:prstGeom>
-          <a:solidFill>
-            <a:srgbClr val="B23A48"/>
-          </a:solidFill>
-          <a:ln/>
-        </p:spPr>
-      </p:sp>
-      <p:sp>
-        <p:nvSpPr>
-          <p:cNvPr id="19" name="Text 17"/>
-          <p:cNvSpPr txBox="1"/>
-          <p:nvPr/>
-        </p:nvSpPr>
-        <p:spPr>
-          <a:xfrm>
-            <a:off x="10378440" y="3831336"/>
-            <a:ext cx="914400" cy="457200"/>
-          </a:xfrm>
-          <a:prstGeom prst="rect">
-            <a:avLst/>
-          </a:prstGeom>
-          <a:noFill/>
-          <a:ln/>
-        </p:spPr>
-        <p:txBody>
-          <a:bodyPr wrap="square" lIns="0" tIns="0" rIns="0" bIns="0" rtlCol="0" anchor="ctr"/>
-          <a:lstStyle/>
-          <a:p>
-            <a:pPr indent="0" marL="0">
-              <a:buNone/>
-            </a:pPr>
-            <a:r>
-              <a:rPr lang="en-US" sz="1300" b="1" dirty="0">
-                <a:solidFill>
-                  <a:srgbClr val="B23A48"/>
-                </a:solidFill>
-                <a:latin typeface="Calibri" pitchFamily="34" charset="0"/>
-                <a:ea typeface="Calibri" pitchFamily="34" charset="-122"/>
-                <a:cs typeface="Calibri" pitchFamily="34" charset="-120"/>
-              </a:rPr>
-              <a:t>3 min</a:t>
+              <a:t>12 min</a:t>
             </a:r>
             <a:endParaRPr lang="en-US" sz="1300" dirty="0"/>
           </a:p>
@@ -3951,8 +3778,8 @@
         </p:nvSpPr>
         <p:spPr>
           <a:xfrm>
-            <a:off x="6284422" y="1600200"/>
-            <a:ext cx="0" cy="2807208"/>
+            <a:off x="5936566" y="1600200"/>
+            <a:ext cx="0" cy="1417320"/>
           </a:xfrm>
           <a:prstGeom prst="line">
             <a:avLst/>
@@ -3965,6 +3792,10 @@
             <a:prstDash val="dash"/>
           </a:ln>
         </p:spPr>
+        <p:txBody>
+          <a:bodyPr/>
+          <a:p/>
+        </p:txBody>
       </p:sp>
       <p:sp>
         <p:nvSpPr>
@@ -3974,7 +3805,7 @@
         </p:nvSpPr>
         <p:spPr>
           <a:xfrm>
-            <a:off x="5735782" y="4498848"/>
+            <a:off x="5387926" y="3108960"/>
             <a:ext cx="1280160" cy="274320"/>
           </a:xfrm>
           <a:prstGeom prst="rect">
@@ -3999,7 +3830,7 @@
                 <a:ea typeface="Calibri" pitchFamily="34" charset="-122"/>
                 <a:cs typeface="Calibri" pitchFamily="34" charset="-120"/>
               </a:rPr>
-              <a:t>mínimo: 4 min</a:t>
+              <a:t>mínimo exigido: 4 min</a:t>
             </a:r>
             <a:endParaRPr lang="en-US" sz="1000" dirty="0"/>
           </a:p>
@@ -4026,6 +3857,10 @@
           </a:solidFill>
           <a:ln/>
         </p:spPr>
+        <p:txBody>
+          <a:bodyPr/>
+          <a:p/>
+        </p:txBody>
       </p:sp>
       <p:sp>
         <p:nvSpPr>
@@ -4060,7 +3895,7 @@
                 <a:ea typeface="Calibri" pitchFamily="34" charset="-122"/>
                 <a:cs typeface="Calibri" pitchFamily="34" charset="-120"/>
               </a:rPr>
-              <a:t>Gilces no participa en el reparto: no aportó al trabajo real, y la defensa evalúa capacidad individual. Muñoz queda con 3 min, por debajo del mínimo — ampliar su bloque 6 antes del simulacro. Validar todo con cronómetro real.</a:t>
+              <a:t>La guía supone equipos de tres a cuatro integrantes y exige al menos cuatro minutos hablados por persona. Este equipo son dos, y cada uno habla muy por encima de ese mínimo. El reparto es de locución: la defensa se rindió de forma individual y cada integrante responde por el proyecto entero.</a:t>
             </a:r>
             <a:endParaRPr lang="en-US" sz="1250" dirty="0"/>
           </a:p>
@@ -4138,7 +3973,7 @@
                 <a:ea typeface="Calibri" pitchFamily="34" charset="-122"/>
                 <a:cs typeface="Calibri" pitchFamily="34" charset="-120"/>
               </a:rPr>
-              <a:t>12</a:t>
+              <a:t>11</a:t>
             </a:r>
             <a:endParaRPr lang="en-US" sz="1000" dirty="0"/>
           </a:p>
@@ -4195,6 +4030,10 @@
           </a:solidFill>
           <a:ln/>
         </p:spPr>
+        <p:txBody>
+          <a:bodyPr/>
+          <a:p/>
+        </p:txBody>
       </p:sp>
       <p:sp>
         <p:nvSpPr>
@@ -4296,6 +4135,10 @@
             <a:prstDash val="solid"/>
           </a:ln>
         </p:spPr>
+        <p:txBody>
+          <a:bodyPr/>
+          <a:p/>
+        </p:txBody>
       </p:sp>
       <p:sp>
         <p:nvSpPr>
@@ -5768,6 +5611,10 @@
           </a:solidFill>
           <a:ln/>
         </p:spPr>
+        <p:txBody>
+          <a:bodyPr/>
+          <a:p/>
+        </p:txBody>
       </p:sp>
       <p:sp>
         <p:nvSpPr>
@@ -5880,6 +5727,10 @@
             </a:outerShdw>
           </a:effectLst>
         </p:spPr>
+        <p:txBody>
+          <a:bodyPr/>
+          <a:p/>
+        </p:txBody>
       </p:sp>
       <p:sp>
         <p:nvSpPr>
@@ -5900,6 +5751,10 @@
           </a:solidFill>
           <a:ln/>
         </p:spPr>
+        <p:txBody>
+          <a:bodyPr/>
+          <a:p/>
+        </p:txBody>
       </p:sp>
       <p:sp>
         <p:nvSpPr>
@@ -5934,7 +5789,7 @@
                 <a:ea typeface="Cambria" pitchFamily="34" charset="-122"/>
                 <a:cs typeface="Cambria" pitchFamily="34" charset="-120"/>
               </a:rPr>
-              <a:t>1</a:t>
+              <a:t>2</a:t>
             </a:r>
             <a:endParaRPr lang="en-US" sz="1600" dirty="0"/>
           </a:p>
@@ -6051,6 +5906,10 @@
             </a:outerShdw>
           </a:effectLst>
         </p:spPr>
+        <p:txBody>
+          <a:bodyPr/>
+          <a:p/>
+        </p:txBody>
       </p:sp>
       <p:sp>
         <p:nvSpPr>
@@ -6071,6 +5930,10 @@
           </a:solidFill>
           <a:ln/>
         </p:spPr>
+        <p:txBody>
+          <a:bodyPr/>
+          <a:p/>
+        </p:txBody>
       </p:sp>
       <p:sp>
         <p:nvSpPr>
@@ -6222,6 +6085,10 @@
             </a:outerShdw>
           </a:effectLst>
         </p:spPr>
+        <p:txBody>
+          <a:bodyPr/>
+          <a:p/>
+        </p:txBody>
       </p:sp>
       <p:sp>
         <p:nvSpPr>
@@ -6242,6 +6109,10 @@
           </a:solidFill>
           <a:ln/>
         </p:spPr>
+        <p:txBody>
+          <a:bodyPr/>
+          <a:p/>
+        </p:txBody>
       </p:sp>
       <p:sp>
         <p:nvSpPr>
@@ -6276,7 +6147,7 @@
                 <a:ea typeface="Cambria" pitchFamily="34" charset="-122"/>
                 <a:cs typeface="Cambria" pitchFamily="34" charset="-120"/>
               </a:rPr>
-              <a:t>3</a:t>
+              <a:t>2</a:t>
             </a:r>
             <a:endParaRPr lang="en-US" sz="1600" dirty="0"/>
           </a:p>
@@ -6432,7 +6303,7 @@
                 <a:ea typeface="Calibri" pitchFamily="34" charset="-122"/>
                 <a:cs typeface="Calibri" pitchFamily="34" charset="-120"/>
               </a:rPr>
-              <a:t>3</a:t>
+              <a:t>2</a:t>
             </a:r>
             <a:endParaRPr lang="en-US" sz="1000" dirty="0"/>
           </a:p>
@@ -6567,6 +6438,10 @@
           </a:solidFill>
           <a:ln/>
         </p:spPr>
+        <p:txBody>
+          <a:bodyPr/>
+          <a:p/>
+        </p:txBody>
       </p:sp>
       <p:sp>
         <p:nvSpPr>
@@ -6626,6 +6501,10 @@
           </a:solidFill>
           <a:ln/>
         </p:spPr>
+        <p:txBody>
+          <a:bodyPr/>
+          <a:p/>
+        </p:txBody>
       </p:sp>
       <p:sp>
         <p:nvSpPr>
@@ -6685,6 +6564,10 @@
           </a:solidFill>
           <a:ln/>
         </p:spPr>
+        <p:txBody>
+          <a:bodyPr/>
+          <a:p/>
+        </p:txBody>
       </p:sp>
       <p:sp>
         <p:nvSpPr>
@@ -6744,6 +6627,10 @@
           </a:solidFill>
           <a:ln/>
         </p:spPr>
+        <p:txBody>
+          <a:bodyPr/>
+          <a:p/>
+        </p:txBody>
       </p:sp>
       <p:sp>
         <p:nvSpPr>
@@ -6803,6 +6690,10 @@
           </a:solidFill>
           <a:ln/>
         </p:spPr>
+        <p:txBody>
+          <a:bodyPr/>
+          <a:p/>
+        </p:txBody>
       </p:sp>
       <p:sp>
         <p:nvSpPr>
@@ -6862,6 +6753,10 @@
           </a:solidFill>
           <a:ln/>
         </p:spPr>
+        <p:txBody>
+          <a:bodyPr/>
+          <a:p/>
+        </p:txBody>
       </p:sp>
       <p:sp>
         <p:nvSpPr>
@@ -7143,7 +7038,7 @@
                 <a:ea typeface="Calibri" pitchFamily="34" charset="-122"/>
                 <a:cs typeface="Calibri" pitchFamily="34" charset="-120"/>
               </a:rPr>
-              <a:t>4</a:t>
+              <a:t>3</a:t>
             </a:r>
             <a:endParaRPr lang="en-US" sz="1000" dirty="0"/>
           </a:p>
@@ -7280,6 +7175,10 @@
           </a:solidFill>
           <a:ln/>
         </p:spPr>
+        <p:txBody>
+          <a:bodyPr/>
+          <a:p/>
+        </p:txBody>
       </p:sp>
       <p:sp>
         <p:nvSpPr>
@@ -7341,6 +7240,10 @@
           </a:solidFill>
           <a:ln/>
         </p:spPr>
+        <p:txBody>
+          <a:bodyPr/>
+          <a:p/>
+        </p:txBody>
       </p:sp>
       <p:sp>
         <p:nvSpPr>
@@ -7402,6 +7305,10 @@
           </a:solidFill>
           <a:ln/>
         </p:spPr>
+        <p:txBody>
+          <a:bodyPr/>
+          <a:p/>
+        </p:txBody>
       </p:sp>
       <p:sp>
         <p:nvSpPr>
@@ -7463,6 +7370,10 @@
           </a:solidFill>
           <a:ln/>
         </p:spPr>
+        <p:txBody>
+          <a:bodyPr/>
+          <a:p/>
+        </p:txBody>
       </p:sp>
       <p:sp>
         <p:nvSpPr>
@@ -7524,6 +7435,10 @@
           </a:solidFill>
           <a:ln/>
         </p:spPr>
+        <p:txBody>
+          <a:bodyPr/>
+          <a:p/>
+        </p:txBody>
       </p:sp>
       <p:sp>
         <p:nvSpPr>
@@ -7585,6 +7500,10 @@
           </a:solidFill>
           <a:ln/>
         </p:spPr>
+        <p:txBody>
+          <a:bodyPr/>
+          <a:p/>
+        </p:txBody>
       </p:sp>
       <p:sp>
         <p:nvSpPr>
@@ -7646,6 +7565,10 @@
           </a:solidFill>
           <a:ln/>
         </p:spPr>
+        <p:txBody>
+          <a:bodyPr/>
+          <a:p/>
+        </p:txBody>
       </p:sp>
       <p:sp>
         <p:nvSpPr>
@@ -7707,6 +7630,10 @@
           </a:solidFill>
           <a:ln/>
         </p:spPr>
+        <p:txBody>
+          <a:bodyPr/>
+          <a:p/>
+        </p:txBody>
       </p:sp>
       <p:sp>
         <p:nvSpPr>
@@ -7819,7 +7746,7 @@
                 <a:ea typeface="Calibri" pitchFamily="34" charset="-122"/>
                 <a:cs typeface="Calibri" pitchFamily="34" charset="-120"/>
               </a:rPr>
-              <a:t>5</a:t>
+              <a:t>4</a:t>
             </a:r>
             <a:endParaRPr lang="en-US" sz="1000" dirty="0"/>
           </a:p>
@@ -8019,6 +7946,10 @@
           </a:solidFill>
           <a:ln/>
         </p:spPr>
+        <p:txBody>
+          <a:bodyPr/>
+          <a:p/>
+        </p:txBody>
       </p:sp>
       <p:sp>
         <p:nvSpPr>
@@ -8145,7 +8076,7 @@
                 <a:ea typeface="Calibri" pitchFamily="34" charset="-122"/>
                 <a:cs typeface="Calibri" pitchFamily="34" charset="-120"/>
               </a:rPr>
-              <a:t>6</a:t>
+              <a:t>5</a:t>
             </a:r>
             <a:endParaRPr lang="en-US" sz="1000" dirty="0"/>
           </a:p>
@@ -8321,6 +8252,10 @@
           </a:solidFill>
           <a:ln/>
         </p:spPr>
+        <p:txBody>
+          <a:bodyPr/>
+          <a:p/>
+        </p:txBody>
       </p:sp>
       <p:sp>
         <p:nvSpPr>
@@ -8458,6 +8393,10 @@
           </a:solidFill>
           <a:ln/>
         </p:spPr>
+        <p:txBody>
+          <a:bodyPr/>
+          <a:p/>
+        </p:txBody>
       </p:sp>
       <p:sp>
         <p:nvSpPr>
@@ -8480,6 +8419,10 @@
           </a:solidFill>
           <a:ln/>
         </p:spPr>
+        <p:txBody>
+          <a:bodyPr/>
+          <a:p/>
+        </p:txBody>
       </p:sp>
       <p:sp>
         <p:nvSpPr>
@@ -8709,7 +8652,7 @@
                 <a:ea typeface="Calibri" pitchFamily="34" charset="-122"/>
                 <a:cs typeface="Calibri" pitchFamily="34" charset="-120"/>
               </a:rPr>
-              <a:t>7</a:t>
+              <a:t>6</a:t>
             </a:r>
             <a:endParaRPr lang="en-US" sz="1000" dirty="0"/>
           </a:p>
@@ -8870,6 +8813,10 @@
           </a:solidFill>
           <a:ln/>
         </p:spPr>
+        <p:txBody>
+          <a:bodyPr/>
+          <a:p/>
+        </p:txBody>
       </p:sp>
       <p:sp>
         <p:nvSpPr>
@@ -8970,6 +8917,10 @@
           </a:solidFill>
           <a:ln/>
         </p:spPr>
+        <p:txBody>
+          <a:bodyPr/>
+          <a:p/>
+        </p:txBody>
       </p:sp>
       <p:sp>
         <p:nvSpPr>
@@ -9160,7 +9111,7 @@
                 <a:ea typeface="Calibri" pitchFamily="34" charset="-122"/>
                 <a:cs typeface="Calibri" pitchFamily="34" charset="-120"/>
               </a:rPr>
-              <a:t>8</a:t>
+              <a:t>7</a:t>
             </a:r>
             <a:endParaRPr lang="en-US" sz="1000" dirty="0"/>
           </a:p>
@@ -9341,6 +9292,10 @@
             <a:prstDash val="solid"/>
           </a:ln>
         </p:spPr>
+        <p:txBody>
+          <a:bodyPr/>
+          <a:p/>
+        </p:txBody>
       </p:sp>
       <p:sp>
         <p:nvSpPr>
@@ -9363,6 +9318,10 @@
           </a:solidFill>
           <a:ln/>
         </p:spPr>
+        <p:txBody>
+          <a:bodyPr/>
+          <a:p/>
+        </p:txBody>
       </p:sp>
       <p:sp>
         <p:nvSpPr>
@@ -9468,6 +9427,10 @@
             <a:prstDash val="solid"/>
           </a:ln>
         </p:spPr>
+        <p:txBody>
+          <a:bodyPr/>
+          <a:p/>
+        </p:txBody>
       </p:sp>
       <p:sp>
         <p:nvSpPr>
@@ -9490,6 +9453,10 @@
           </a:solidFill>
           <a:ln/>
         </p:spPr>
+        <p:txBody>
+          <a:bodyPr/>
+          <a:p/>
+        </p:txBody>
       </p:sp>
       <p:sp>
         <p:nvSpPr>
@@ -9595,6 +9562,10 @@
             <a:prstDash val="solid"/>
           </a:ln>
         </p:spPr>
+        <p:txBody>
+          <a:bodyPr/>
+          <a:p/>
+        </p:txBody>
       </p:sp>
       <p:sp>
         <p:nvSpPr>
@@ -9617,6 +9588,10 @@
           </a:solidFill>
           <a:ln/>
         </p:spPr>
+        <p:txBody>
+          <a:bodyPr/>
+          <a:p/>
+        </p:txBody>
       </p:sp>
       <p:sp>
         <p:nvSpPr>
@@ -9722,6 +9697,10 @@
             <a:prstDash val="solid"/>
           </a:ln>
         </p:spPr>
+        <p:txBody>
+          <a:bodyPr/>
+          <a:p/>
+        </p:txBody>
       </p:sp>
       <p:sp>
         <p:nvSpPr>
@@ -9744,6 +9723,10 @@
           </a:solidFill>
           <a:ln/>
         </p:spPr>
+        <p:txBody>
+          <a:bodyPr/>
+          <a:p/>
+        </p:txBody>
       </p:sp>
       <p:sp>
         <p:nvSpPr>
@@ -9895,7 +9878,7 @@
                 <a:ea typeface="Calibri" pitchFamily="34" charset="-122"/>
                 <a:cs typeface="Calibri" pitchFamily="34" charset="-120"/>
               </a:rPr>
-              <a:t>9</a:t>
+              <a:t>8</a:t>
             </a:r>
             <a:endParaRPr lang="en-US" sz="1000" dirty="0"/>
           </a:p>

</xml_diff>

<commit_message>
feat(defensa): anade el bloque de verificacion, trazabilidad y campo, y pasa el mazo a tres integrantes
</commit_message>
<xml_diff>
--- a/08_Defensa/presentacion.pptx
+++ b/08_Defensa/presentacion.pptx
@@ -18,6 +18,9 @@
     <p:sldId id="264" r:id="rId9"/>
     <p:sldId id="265" r:id="rId10"/>
     <p:sldId id="266" r:id="rId11"/>
+    <p:sldId id="269" r:id="rId19"/>
+    <p:sldId id="270" r:id="rId20"/>
+    <p:sldId id="271" r:id="rId21"/>
     <p:sldId id="267" r:id="rId12"/>
     <p:sldId id="268" r:id="rId13"/>
   </p:sldIdLst>
@@ -1875,7 +1878,7 @@
                 <a:ea typeface="Calibri" pitchFamily="34" charset="-122"/>
                 <a:cs typeface="Calibri" pitchFamily="34" charset="-120"/>
               </a:rPr>
-              <a:t>Sánchez Cornejo, Gary Alberto · Muñoz Quiñónez, Yeranick Esther</a:t>
+              <a:t>Sánchez Cornejo, Gary Alberto · Muñoz Quiñónez, Yeranick Esther · Cedeño Ávila, Winston Damián</a:t>
             </a:r>
             <a:endParaRPr lang="en-US" sz="1200" dirty="0"/>
           </a:p>
@@ -2575,6 +2578,1182 @@
 </file>
 
 <file path=ppt/slides/slide11.xml><?xml version="1.0" encoding="utf-8"?>
+<p:sld xmlns:a="http://schemas.openxmlformats.org/drawingml/2006/main" xmlns:p="http://schemas.openxmlformats.org/presentationml/2006/main" xmlns:r="http://schemas.openxmlformats.org/officeDocument/2006/relationships">
+  <p:cSld>
+    <p:spTree>
+      <p:nvGrpSpPr>
+        <p:cNvPr id="1" name=""/>
+        <p:cNvGrpSpPr/>
+        <p:nvPr/>
+      </p:nvGrpSpPr>
+      <p:grpSpPr/>
+      <p:sp>
+        <p:nvSpPr>
+          <p:cNvPr id="2" name="TextBox 1"/>
+          <p:cNvSpPr txBox="1"/>
+          <p:nvPr/>
+        </p:nvSpPr>
+        <p:spPr>
+          <a:xfrm>
+            <a:off x="548640" y="182880"/>
+            <a:ext cx="11064240" cy="274320"/>
+          </a:xfrm>
+          <a:prstGeom prst="rect">
+            <a:avLst/>
+          </a:prstGeom>
+          <a:noFill/>
+        </p:spPr>
+        <p:txBody>
+          <a:bodyPr wrap="square">
+            <a:spAutoFit/>
+          </a:bodyPr>
+          <a:lstStyle/>
+          <a:p>
+            <a:r>
+              <a:rPr sz="1200" b="1">
+                <a:solidFill>
+                  <a:srgbClr val="52796F"/>
+                </a:solidFill>
+                <a:latin typeface="Calibri"/>
+              </a:rPr>
+              <a:t>BLOQUE 8 · 3 MIN — VERIFICACIÓN Y CONTROL DE CAMBIOS</a:t>
+            </a:r>
+          </a:p>
+        </p:txBody>
+      </p:sp>
+      <p:sp>
+        <p:nvSpPr>
+          <p:cNvPr id="3" name="TextBox 2"/>
+          <p:cNvSpPr txBox="1"/>
+          <p:nvPr/>
+        </p:nvSpPr>
+        <p:spPr>
+          <a:xfrm>
+            <a:off x="548640" y="457200"/>
+            <a:ext cx="11064240" cy="822960"/>
+          </a:xfrm>
+          <a:prstGeom prst="rect">
+            <a:avLst/>
+          </a:prstGeom>
+          <a:noFill/>
+        </p:spPr>
+        <p:txBody>
+          <a:bodyPr wrap="square">
+            <a:spAutoFit/>
+          </a:bodyPr>
+          <a:lstStyle/>
+          <a:p>
+            <a:r>
+              <a:rPr sz="3200" b="1">
+                <a:solidFill>
+                  <a:srgbClr val="1B4332"/>
+                </a:solidFill>
+                <a:latin typeface="Cambria"/>
+              </a:rPr>
+              <a:t>La especificación se inspeccionó con método, no se leyó por encima</a:t>
+            </a:r>
+          </a:p>
+        </p:txBody>
+      </p:sp>
+      <p:sp>
+        <p:nvSpPr>
+          <p:cNvPr id="4" name="TextBox 3"/>
+          <p:cNvSpPr txBox="1"/>
+          <p:nvPr/>
+        </p:nvSpPr>
+        <p:spPr>
+          <a:xfrm>
+            <a:off x="731520" y="1600200"/>
+            <a:ext cx="10698480" cy="320040"/>
+          </a:xfrm>
+          <a:prstGeom prst="rect">
+            <a:avLst/>
+          </a:prstGeom>
+          <a:noFill/>
+        </p:spPr>
+        <p:txBody>
+          <a:bodyPr wrap="square">
+            <a:spAutoFit/>
+          </a:bodyPr>
+          <a:lstStyle/>
+          <a:p>
+            <a:r>
+              <a:rPr sz="1500" b="1">
+                <a:solidFill>
+                  <a:srgbClr val="1B4332"/>
+                </a:solidFill>
+                <a:latin typeface="Calibri"/>
+              </a:rPr>
+              <a:t>Inspección de Fagan INS-01 — 16 defectos</a:t>
+            </a:r>
+          </a:p>
+        </p:txBody>
+      </p:sp>
+      <p:sp>
+        <p:nvSpPr>
+          <p:cNvPr id="5" name="TextBox 4"/>
+          <p:cNvSpPr txBox="1"/>
+          <p:nvPr/>
+        </p:nvSpPr>
+        <p:spPr>
+          <a:xfrm>
+            <a:off x="731520" y="1947672"/>
+            <a:ext cx="10698480" cy="640080"/>
+          </a:xfrm>
+          <a:prstGeom prst="rect">
+            <a:avLst/>
+          </a:prstGeom>
+          <a:noFill/>
+        </p:spPr>
+        <p:txBody>
+          <a:bodyPr wrap="square">
+            <a:spAutoFit/>
+          </a:bodyPr>
+          <a:lstStyle/>
+          <a:p>
+            <a:r>
+              <a:rPr sz="1300" b="0">
+                <a:solidFill>
+                  <a:srgbClr val="6B7A72"/>
+                </a:solidFill>
+                <a:latin typeface="Calibri"/>
+              </a:rPr>
+              <a:t>3 críticos, 9 mayores, 4 menores. Densidad de 0,64 defectos por requisito funcional. Cinco roles repartidos entre tres personas; autor y moderador nunca coinciden.</a:t>
+            </a:r>
+          </a:p>
+        </p:txBody>
+      </p:sp>
+      <p:sp>
+        <p:nvSpPr>
+          <p:cNvPr id="6" name="TextBox 5"/>
+          <p:cNvSpPr txBox="1"/>
+          <p:nvPr/>
+        </p:nvSpPr>
+        <p:spPr>
+          <a:xfrm>
+            <a:off x="731520" y="2651760"/>
+            <a:ext cx="10698480" cy="320040"/>
+          </a:xfrm>
+          <a:prstGeom prst="rect">
+            <a:avLst/>
+          </a:prstGeom>
+          <a:noFill/>
+        </p:spPr>
+        <p:txBody>
+          <a:bodyPr wrap="square">
+            <a:spAutoFit/>
+          </a:bodyPr>
+          <a:lstStyle/>
+          <a:p>
+            <a:r>
+              <a:rPr sz="1500" b="1">
+                <a:solidFill>
+                  <a:srgbClr val="1B4332"/>
+                </a:solidFill>
+                <a:latin typeface="Calibri"/>
+              </a:rPr>
+              <a:t>Re-inspección REINS-01 — 15 cerrados, 1 residual</a:t>
+            </a:r>
+          </a:p>
+        </p:txBody>
+      </p:sp>
+      <p:sp>
+        <p:nvSpPr>
+          <p:cNvPr id="7" name="TextBox 6"/>
+          <p:cNvSpPr txBox="1"/>
+          <p:nvPr/>
+        </p:nvSpPr>
+        <p:spPr>
+          <a:xfrm>
+            <a:off x="731520" y="2999232"/>
+            <a:ext cx="10698480" cy="640080"/>
+          </a:xfrm>
+          <a:prstGeom prst="rect">
+            <a:avLst/>
+          </a:prstGeom>
+          <a:noFill/>
+        </p:spPr>
+        <p:txBody>
+          <a:bodyPr wrap="square">
+            <a:spAutoFit/>
+          </a:bodyPr>
+          <a:lstStyle/>
+          <a:p>
+            <a:r>
+              <a:rPr sz="1300" b="0">
+                <a:solidFill>
+                  <a:srgbClr val="6B7A72"/>
+                </a:solidFill>
+                <a:latin typeface="Calibri"/>
+              </a:rPr>
+              <a:t>Cada defecto lo verifica quien no lo corrigió. El residual es DEF-06, la apertura individual de cámara.</a:t>
+            </a:r>
+          </a:p>
+        </p:txBody>
+      </p:sp>
+      <p:sp>
+        <p:nvSpPr>
+          <p:cNvPr id="8" name="TextBox 7"/>
+          <p:cNvSpPr txBox="1"/>
+          <p:nvPr/>
+        </p:nvSpPr>
+        <p:spPr>
+          <a:xfrm>
+            <a:off x="731520" y="3703320"/>
+            <a:ext cx="10698480" cy="320040"/>
+          </a:xfrm>
+          <a:prstGeom prst="rect">
+            <a:avLst/>
+          </a:prstGeom>
+          <a:noFill/>
+        </p:spPr>
+        <p:txBody>
+          <a:bodyPr wrap="square">
+            <a:spAutoFit/>
+          </a:bodyPr>
+          <a:lstStyle/>
+          <a:p>
+            <a:r>
+              <a:rPr sz="1500" b="1">
+                <a:solidFill>
+                  <a:srgbClr val="1B4332"/>
+                </a:solidFill>
+                <a:latin typeface="Calibri"/>
+              </a:rPr>
+              <a:t>Comité de control de cambios CCB-01 — 4 solicitudes</a:t>
+            </a:r>
+          </a:p>
+        </p:txBody>
+      </p:sp>
+      <p:sp>
+        <p:nvSpPr>
+          <p:cNvPr id="9" name="TextBox 8"/>
+          <p:cNvSpPr txBox="1"/>
+          <p:nvPr/>
+        </p:nvSpPr>
+        <p:spPr>
+          <a:xfrm>
+            <a:off x="731520" y="4050791"/>
+            <a:ext cx="10698480" cy="640080"/>
+          </a:xfrm>
+          <a:prstGeom prst="rect">
+            <a:avLst/>
+          </a:prstGeom>
+          <a:noFill/>
+        </p:spPr>
+        <p:txBody>
+          <a:bodyPr wrap="square">
+            <a:spAutoFit/>
+          </a:bodyPr>
+          <a:lstStyle/>
+          <a:p>
+            <a:r>
+              <a:rPr sz="1300" b="0">
+                <a:solidFill>
+                  <a:srgbClr val="6B7A72"/>
+                </a:solidFill>
+                <a:latin typeface="Calibri"/>
+              </a:rPr>
+              <a:t>Tres aprobadas. SC-03 queda diferida porque no se verificó si la interfaz instalada expone el flujo de una cámara concreta.</a:t>
+            </a:r>
+          </a:p>
+        </p:txBody>
+      </p:sp>
+      <p:sp>
+        <p:nvSpPr>
+          <p:cNvPr id="10" name="TextBox 9"/>
+          <p:cNvSpPr txBox="1"/>
+          <p:nvPr/>
+        </p:nvSpPr>
+        <p:spPr>
+          <a:xfrm>
+            <a:off x="914400" y="5074920"/>
+            <a:ext cx="10332720" cy="914400"/>
+          </a:xfrm>
+          <a:prstGeom prst="rect">
+            <a:avLst/>
+          </a:prstGeom>
+          <a:noFill/>
+        </p:spPr>
+        <p:txBody>
+          <a:bodyPr wrap="square">
+            <a:spAutoFit/>
+          </a:bodyPr>
+          <a:lstStyle/>
+          <a:p>
+            <a:r>
+              <a:rPr sz="1500" b="1">
+                <a:solidFill>
+                  <a:srgbClr val="1B4332"/>
+                </a:solidFill>
+                <a:latin typeface="Calibri"/>
+              </a:rPr>
+              <a:t>Corrección = 1 residual / 25 RF = 0,04, frente a la referencia de 0,05. El margen es de un solo defecto, y lo decimos así.</a:t>
+            </a:r>
+          </a:p>
+        </p:txBody>
+      </p:sp>
+      <p:sp>
+        <p:nvSpPr>
+          <p:cNvPr id="11" name="TextBox 10"/>
+          <p:cNvSpPr txBox="1"/>
+          <p:nvPr/>
+        </p:nvSpPr>
+        <p:spPr>
+          <a:xfrm>
+            <a:off x="457200" y="6492240"/>
+            <a:ext cx="7315200" cy="274320"/>
+          </a:xfrm>
+          <a:prstGeom prst="rect">
+            <a:avLst/>
+          </a:prstGeom>
+          <a:noFill/>
+        </p:spPr>
+        <p:txBody>
+          <a:bodyPr wrap="square">
+            <a:spAutoFit/>
+          </a:bodyPr>
+          <a:lstStyle/>
+          <a:p>
+            <a:r>
+              <a:rPr sz="1000" b="0">
+                <a:solidFill>
+                  <a:srgbClr val="8A9A93"/>
+                </a:solidFill>
+                <a:latin typeface="Calibri"/>
+              </a:rPr>
+              <a:t>SIGA · Equipo FGMMN · Entrega 4 (2B)</a:t>
+            </a:r>
+          </a:p>
+        </p:txBody>
+      </p:sp>
+      <p:sp>
+        <p:nvSpPr>
+          <p:cNvPr id="12" name="TextBox 11"/>
+          <p:cNvSpPr txBox="1"/>
+          <p:nvPr/>
+        </p:nvSpPr>
+        <p:spPr>
+          <a:xfrm>
+            <a:off x="11247120" y="6492240"/>
+            <a:ext cx="457200" cy="274320"/>
+          </a:xfrm>
+          <a:prstGeom prst="rect">
+            <a:avLst/>
+          </a:prstGeom>
+          <a:noFill/>
+        </p:spPr>
+        <p:txBody>
+          <a:bodyPr wrap="square">
+            <a:spAutoFit/>
+          </a:bodyPr>
+          <a:lstStyle/>
+          <a:p>
+            <a:r>
+              <a:rPr sz="1000" b="0">
+                <a:solidFill>
+                  <a:srgbClr val="8A9A93"/>
+                </a:solidFill>
+                <a:latin typeface="Calibri"/>
+              </a:rPr>
+              <a:t>11</a:t>
+            </a:r>
+          </a:p>
+        </p:txBody>
+      </p:sp>
+    </p:spTree>
+  </p:cSld>
+  <p:clrMapOvr>
+    <a:masterClrMapping/>
+  </p:clrMapOvr>
+</p:sld>
+</file>
+
+<file path=ppt/slides/slide12.xml><?xml version="1.0" encoding="utf-8"?>
+<p:sld xmlns:a="http://schemas.openxmlformats.org/drawingml/2006/main" xmlns:p="http://schemas.openxmlformats.org/presentationml/2006/main" xmlns:r="http://schemas.openxmlformats.org/officeDocument/2006/relationships">
+  <p:cSld>
+    <p:spTree>
+      <p:nvGrpSpPr>
+        <p:cNvPr id="1" name=""/>
+        <p:cNvGrpSpPr/>
+        <p:nvPr/>
+      </p:nvGrpSpPr>
+      <p:grpSpPr/>
+      <p:sp>
+        <p:nvSpPr>
+          <p:cNvPr id="2" name="TextBox 1"/>
+          <p:cNvSpPr txBox="1"/>
+          <p:nvPr/>
+        </p:nvSpPr>
+        <p:spPr>
+          <a:xfrm>
+            <a:off x="548640" y="182880"/>
+            <a:ext cx="11064240" cy="274320"/>
+          </a:xfrm>
+          <a:prstGeom prst="rect">
+            <a:avLst/>
+          </a:prstGeom>
+          <a:noFill/>
+        </p:spPr>
+        <p:txBody>
+          <a:bodyPr wrap="square">
+            <a:spAutoFit/>
+          </a:bodyPr>
+          <a:lstStyle/>
+          <a:p>
+            <a:r>
+              <a:rPr sz="1200" b="1">
+                <a:solidFill>
+                  <a:srgbClr val="52796F"/>
+                </a:solidFill>
+                <a:latin typeface="Calibri"/>
+              </a:rPr>
+              <a:t>BLOQUE 8 · 3 MIN — TRAZABILIDAD Y GESTIÓN</a:t>
+            </a:r>
+          </a:p>
+        </p:txBody>
+      </p:sp>
+      <p:sp>
+        <p:nvSpPr>
+          <p:cNvPr id="3" name="TextBox 2"/>
+          <p:cNvSpPr txBox="1"/>
+          <p:nvPr/>
+        </p:nvSpPr>
+        <p:spPr>
+          <a:xfrm>
+            <a:off x="548640" y="457200"/>
+            <a:ext cx="11064240" cy="822960"/>
+          </a:xfrm>
+          <a:prstGeom prst="rect">
+            <a:avLst/>
+          </a:prstGeom>
+          <a:noFill/>
+        </p:spPr>
+        <p:txBody>
+          <a:bodyPr wrap="square">
+            <a:spAutoFit/>
+          </a:bodyPr>
+          <a:lstStyle/>
+          <a:p>
+            <a:r>
+              <a:rPr sz="3200" b="1">
+                <a:solidFill>
+                  <a:srgbClr val="1B4332"/>
+                </a:solidFill>
+                <a:latin typeface="Cambria"/>
+              </a:rPr>
+              <a:t>El tablero dice lo mismo que la matriz, y se comprueba por script</a:t>
+            </a:r>
+          </a:p>
+        </p:txBody>
+      </p:sp>
+      <p:sp>
+        <p:nvSpPr>
+          <p:cNvPr id="4" name="TextBox 3"/>
+          <p:cNvSpPr txBox="1"/>
+          <p:nvPr/>
+        </p:nvSpPr>
+        <p:spPr>
+          <a:xfrm>
+            <a:off x="731520" y="1600200"/>
+            <a:ext cx="10698480" cy="320040"/>
+          </a:xfrm>
+          <a:prstGeom prst="rect">
+            <a:avLst/>
+          </a:prstGeom>
+          <a:noFill/>
+        </p:spPr>
+        <p:txBody>
+          <a:bodyPr wrap="square">
+            <a:spAutoFit/>
+          </a:bodyPr>
+          <a:lstStyle/>
+          <a:p>
+            <a:r>
+              <a:rPr sz="1500" b="1">
+                <a:solidFill>
+                  <a:srgbClr val="1B4332"/>
+                </a:solidFill>
+                <a:latin typeface="Calibri"/>
+              </a:rPr>
+              <a:t>Matriz de trazabilidad — 74 filas</a:t>
+            </a:r>
+          </a:p>
+        </p:txBody>
+      </p:sp>
+      <p:sp>
+        <p:nvSpPr>
+          <p:cNvPr id="5" name="TextBox 4"/>
+          <p:cNvSpPr txBox="1"/>
+          <p:nvPr/>
+        </p:nvSpPr>
+        <p:spPr>
+          <a:xfrm>
+            <a:off x="731520" y="1947672"/>
+            <a:ext cx="10698480" cy="640080"/>
+          </a:xfrm>
+          <a:prstGeom prst="rect">
+            <a:avLst/>
+          </a:prstGeom>
+          <a:noFill/>
+        </p:spPr>
+        <p:txBody>
+          <a:bodyPr wrap="square">
+            <a:spAutoFit/>
+          </a:bodyPr>
+          <a:lstStyle/>
+          <a:p>
+            <a:r>
+              <a:rPr sz="1300" b="0">
+                <a:solidFill>
+                  <a:srgbClr val="6B7A72"/>
+                </a:solidFill>
+                <a:latin typeface="Calibri"/>
+              </a:rPr>
+              <a:t>41 con la cadena completa de fuente a criterio de aceptación. Las 74 tienen todos sus eslabones declarados: ninguna celda ambigua.</a:t>
+            </a:r>
+          </a:p>
+        </p:txBody>
+      </p:sp>
+      <p:sp>
+        <p:nvSpPr>
+          <p:cNvPr id="6" name="TextBox 5"/>
+          <p:cNvSpPr txBox="1"/>
+          <p:nvPr/>
+        </p:nvSpPr>
+        <p:spPr>
+          <a:xfrm>
+            <a:off x="731520" y="2651760"/>
+            <a:ext cx="10698480" cy="320040"/>
+          </a:xfrm>
+          <a:prstGeom prst="rect">
+            <a:avLst/>
+          </a:prstGeom>
+          <a:noFill/>
+        </p:spPr>
+        <p:txBody>
+          <a:bodyPr wrap="square">
+            <a:spAutoFit/>
+          </a:bodyPr>
+          <a:lstStyle/>
+          <a:p>
+            <a:r>
+              <a:rPr sz="1500" b="1">
+                <a:solidFill>
+                  <a:srgbClr val="1B4332"/>
+                </a:solidFill>
+                <a:latin typeface="Calibri"/>
+              </a:rPr>
+              <a:t>Tablero de gestión — 60 actividades</a:t>
+            </a:r>
+          </a:p>
+        </p:txBody>
+      </p:sp>
+      <p:sp>
+        <p:nvSpPr>
+          <p:cNvPr id="7" name="TextBox 6"/>
+          <p:cNvSpPr txBox="1"/>
+          <p:nvPr/>
+        </p:nvSpPr>
+        <p:spPr>
+          <a:xfrm>
+            <a:off x="731520" y="2999232"/>
+            <a:ext cx="10698480" cy="640080"/>
+          </a:xfrm>
+          <a:prstGeom prst="rect">
+            <a:avLst/>
+          </a:prstGeom>
+          <a:noFill/>
+        </p:spPr>
+        <p:txBody>
+          <a:bodyPr wrap="square">
+            <a:spAutoFit/>
+          </a:bodyPr>
+          <a:lstStyle/>
+          <a:p>
+            <a:r>
+              <a:rPr sz="1300" b="0">
+                <a:solidFill>
+                  <a:srgbClr val="6B7A72"/>
+                </a:solidFill>
+                <a:latin typeface="Calibri"/>
+              </a:rPr>
+              <a:t>25 requisitos funcionales, 24 no funcionales y 11 restricciones de diseño, cada uno con su evidencia de origen, su historia y su caso de prueba.</a:t>
+            </a:r>
+          </a:p>
+        </p:txBody>
+      </p:sp>
+      <p:sp>
+        <p:nvSpPr>
+          <p:cNvPr id="8" name="TextBox 7"/>
+          <p:cNvSpPr txBox="1"/>
+          <p:nvPr/>
+        </p:nvSpPr>
+        <p:spPr>
+          <a:xfrm>
+            <a:off x="731520" y="3703320"/>
+            <a:ext cx="10698480" cy="320040"/>
+          </a:xfrm>
+          <a:prstGeom prst="rect">
+            <a:avLst/>
+          </a:prstGeom>
+          <a:noFill/>
+        </p:spPr>
+        <p:txBody>
+          <a:bodyPr wrap="square">
+            <a:spAutoFit/>
+          </a:bodyPr>
+          <a:lstStyle/>
+          <a:p>
+            <a:r>
+              <a:rPr sz="1500" b="1">
+                <a:solidFill>
+                  <a:srgbClr val="1B4332"/>
+                </a:solidFill>
+                <a:latin typeface="Calibri"/>
+              </a:rPr>
+              <a:t>Sincronización — 100 %</a:t>
+            </a:r>
+          </a:p>
+        </p:txBody>
+      </p:sp>
+      <p:sp>
+        <p:nvSpPr>
+          <p:cNvPr id="9" name="TextBox 8"/>
+          <p:cNvSpPr txBox="1"/>
+          <p:nvPr/>
+        </p:nvSpPr>
+        <p:spPr>
+          <a:xfrm>
+            <a:off x="731520" y="4050791"/>
+            <a:ext cx="10698480" cy="640080"/>
+          </a:xfrm>
+          <a:prstGeom prst="rect">
+            <a:avLst/>
+          </a:prstGeom>
+          <a:noFill/>
+        </p:spPr>
+        <p:txBody>
+          <a:bodyPr wrap="square">
+            <a:spAutoFit/>
+          </a:bodyPr>
+          <a:lstStyle/>
+          <a:p>
+            <a:r>
+              <a:rPr sz="1300" b="0">
+                <a:solidFill>
+                  <a:srgbClr val="6B7A72"/>
+                </a:solidFill>
+                <a:latin typeface="Calibri"/>
+              </a:rPr>
+              <a:t>60 de 60. Ni un requisito sin actividad, ni una actividad sin requisito. Se recalcula con un script sobre el export del tablero.</a:t>
+            </a:r>
+          </a:p>
+        </p:txBody>
+      </p:sp>
+      <p:sp>
+        <p:nvSpPr>
+          <p:cNvPr id="10" name="TextBox 9"/>
+          <p:cNvSpPr txBox="1"/>
+          <p:nvPr/>
+        </p:nvSpPr>
+        <p:spPr>
+          <a:xfrm>
+            <a:off x="914400" y="5074920"/>
+            <a:ext cx="10332720" cy="914400"/>
+          </a:xfrm>
+          <a:prstGeom prst="rect">
+            <a:avLst/>
+          </a:prstGeom>
+          <a:noFill/>
+        </p:spPr>
+        <p:txBody>
+          <a:bodyPr wrap="square">
+            <a:spAutoFit/>
+          </a:bodyPr>
+          <a:lstStyle/>
+          <a:p>
+            <a:r>
+              <a:rPr sz="1500" b="1">
+                <a:solidFill>
+                  <a:srgbClr val="1B4332"/>
+                </a:solidFill>
+                <a:latin typeface="Calibri"/>
+              </a:rPr>
+              <a:t>Ese 100 % mide correspondencia entre dos listas, no avance: las sesenta actividades están en «Por hacer», que es su estado real.</a:t>
+            </a:r>
+          </a:p>
+        </p:txBody>
+      </p:sp>
+      <p:sp>
+        <p:nvSpPr>
+          <p:cNvPr id="11" name="TextBox 10"/>
+          <p:cNvSpPr txBox="1"/>
+          <p:nvPr/>
+        </p:nvSpPr>
+        <p:spPr>
+          <a:xfrm>
+            <a:off x="457200" y="6492240"/>
+            <a:ext cx="7315200" cy="274320"/>
+          </a:xfrm>
+          <a:prstGeom prst="rect">
+            <a:avLst/>
+          </a:prstGeom>
+          <a:noFill/>
+        </p:spPr>
+        <p:txBody>
+          <a:bodyPr wrap="square">
+            <a:spAutoFit/>
+          </a:bodyPr>
+          <a:lstStyle/>
+          <a:p>
+            <a:r>
+              <a:rPr sz="1000" b="0">
+                <a:solidFill>
+                  <a:srgbClr val="8A9A93"/>
+                </a:solidFill>
+                <a:latin typeface="Calibri"/>
+              </a:rPr>
+              <a:t>SIGA · Equipo FGMMN · Entrega 4 (2B)</a:t>
+            </a:r>
+          </a:p>
+        </p:txBody>
+      </p:sp>
+      <p:sp>
+        <p:nvSpPr>
+          <p:cNvPr id="12" name="TextBox 11"/>
+          <p:cNvSpPr txBox="1"/>
+          <p:nvPr/>
+        </p:nvSpPr>
+        <p:spPr>
+          <a:xfrm>
+            <a:off x="11247120" y="6492240"/>
+            <a:ext cx="457200" cy="274320"/>
+          </a:xfrm>
+          <a:prstGeom prst="rect">
+            <a:avLst/>
+          </a:prstGeom>
+          <a:noFill/>
+        </p:spPr>
+        <p:txBody>
+          <a:bodyPr wrap="square">
+            <a:spAutoFit/>
+          </a:bodyPr>
+          <a:lstStyle/>
+          <a:p>
+            <a:r>
+              <a:rPr sz="1000" b="0">
+                <a:solidFill>
+                  <a:srgbClr val="8A9A93"/>
+                </a:solidFill>
+                <a:latin typeface="Calibri"/>
+              </a:rPr>
+              <a:t>12</a:t>
+            </a:r>
+          </a:p>
+        </p:txBody>
+      </p:sp>
+    </p:spTree>
+  </p:cSld>
+  <p:clrMapOvr>
+    <a:masterClrMapping/>
+  </p:clrMapOvr>
+</p:sld>
+</file>
+
+<file path=ppt/slides/slide13.xml><?xml version="1.0" encoding="utf-8"?>
+<p:sld xmlns:a="http://schemas.openxmlformats.org/drawingml/2006/main" xmlns:p="http://schemas.openxmlformats.org/presentationml/2006/main" xmlns:r="http://schemas.openxmlformats.org/officeDocument/2006/relationships">
+  <p:cSld>
+    <p:spTree>
+      <p:nvGrpSpPr>
+        <p:cNvPr id="1" name=""/>
+        <p:cNvGrpSpPr/>
+        <p:nvPr/>
+      </p:nvGrpSpPr>
+      <p:grpSpPr/>
+      <p:sp>
+        <p:nvSpPr>
+          <p:cNvPr id="2" name="TextBox 1"/>
+          <p:cNvSpPr txBox="1"/>
+          <p:nvPr/>
+        </p:nvSpPr>
+        <p:spPr>
+          <a:xfrm>
+            <a:off x="548640" y="182880"/>
+            <a:ext cx="11064240" cy="274320"/>
+          </a:xfrm>
+          <a:prstGeom prst="rect">
+            <a:avLst/>
+          </a:prstGeom>
+          <a:noFill/>
+        </p:spPr>
+        <p:txBody>
+          <a:bodyPr wrap="square">
+            <a:spAutoFit/>
+          </a:bodyPr>
+          <a:lstStyle/>
+          <a:p>
+            <a:r>
+              <a:rPr sz="1200" b="1">
+                <a:solidFill>
+                  <a:srgbClr val="52796F"/>
+                </a:solidFill>
+                <a:latin typeface="Calibri"/>
+              </a:rPr>
+              <a:t>BLOQUE 8 · 3 MIN — EVIDENCIA DE CAMPO</a:t>
+            </a:r>
+          </a:p>
+        </p:txBody>
+      </p:sp>
+      <p:sp>
+        <p:nvSpPr>
+          <p:cNvPr id="3" name="TextBox 2"/>
+          <p:cNvSpPr txBox="1"/>
+          <p:nvPr/>
+        </p:nvSpPr>
+        <p:spPr>
+          <a:xfrm>
+            <a:off x="548640" y="457200"/>
+            <a:ext cx="11064240" cy="822960"/>
+          </a:xfrm>
+          <a:prstGeom prst="rect">
+            <a:avLst/>
+          </a:prstGeom>
+          <a:noFill/>
+        </p:spPr>
+        <p:txBody>
+          <a:bodyPr wrap="square">
+            <a:spAutoFit/>
+          </a:bodyPr>
+          <a:lstStyle/>
+          <a:p>
+            <a:r>
+              <a:rPr sz="3200" b="1">
+                <a:solidFill>
+                  <a:srgbClr val="1B4332"/>
+                </a:solidFill>
+                <a:latin typeface="Cambria"/>
+              </a:rPr>
+              <a:t>N = 16 entrevistas, 9 sesiones de validación, 12 notas de campo</a:t>
+            </a:r>
+          </a:p>
+        </p:txBody>
+      </p:sp>
+      <p:sp>
+        <p:nvSpPr>
+          <p:cNvPr id="4" name="TextBox 3"/>
+          <p:cNvSpPr txBox="1"/>
+          <p:nvPr/>
+        </p:nvSpPr>
+        <p:spPr>
+          <a:xfrm>
+            <a:off x="731520" y="1600200"/>
+            <a:ext cx="10698480" cy="320040"/>
+          </a:xfrm>
+          <a:prstGeom prst="rect">
+            <a:avLst/>
+          </a:prstGeom>
+          <a:noFill/>
+        </p:spPr>
+        <p:txBody>
+          <a:bodyPr wrap="square">
+            <a:spAutoFit/>
+          </a:bodyPr>
+          <a:lstStyle/>
+          <a:p>
+            <a:r>
+              <a:rPr sz="1500" b="1">
+                <a:solidFill>
+                  <a:srgbClr val="1B4332"/>
+                </a:solidFill>
+                <a:latin typeface="Calibri"/>
+              </a:rPr>
+              <a:t>Corpus — 16 entrevistas transcritas y anonimizadas</a:t>
+            </a:r>
+          </a:p>
+        </p:txBody>
+      </p:sp>
+      <p:sp>
+        <p:nvSpPr>
+          <p:cNvPr id="5" name="TextBox 4"/>
+          <p:cNvSpPr txBox="1"/>
+          <p:nvPr/>
+        </p:nvSpPr>
+        <p:spPr>
+          <a:xfrm>
+            <a:off x="731520" y="1947672"/>
+            <a:ext cx="10698480" cy="640080"/>
+          </a:xfrm>
+          <a:prstGeom prst="rect">
+            <a:avLst/>
+          </a:prstGeom>
+          <a:noFill/>
+        </p:spPr>
+        <p:txBody>
+          <a:bodyPr wrap="square">
+            <a:spAutoFit/>
+          </a:bodyPr>
+          <a:lstStyle/>
+          <a:p>
+            <a:r>
+              <a:rPr sz="1300" b="0">
+                <a:solidFill>
+                  <a:srgbClr val="6B7A72"/>
+                </a:solidFill>
+                <a:latin typeface="Calibri"/>
+              </a:rPr>
+              <a:t>Diez codificadas temáticamente. Las seis de la ronda terminal están transcritas y su codificación se declara pendiente en el manuscrito, en la amenaza T4.</a:t>
+            </a:r>
+          </a:p>
+        </p:txBody>
+      </p:sp>
+      <p:sp>
+        <p:nvSpPr>
+          <p:cNvPr id="6" name="TextBox 5"/>
+          <p:cNvSpPr txBox="1"/>
+          <p:nvPr/>
+        </p:nvSpPr>
+        <p:spPr>
+          <a:xfrm>
+            <a:off x="731520" y="2651760"/>
+            <a:ext cx="10698480" cy="320040"/>
+          </a:xfrm>
+          <a:prstGeom prst="rect">
+            <a:avLst/>
+          </a:prstGeom>
+          <a:noFill/>
+        </p:spPr>
+        <p:txBody>
+          <a:bodyPr wrap="square">
+            <a:spAutoFit/>
+          </a:bodyPr>
+          <a:lstStyle/>
+          <a:p>
+            <a:r>
+              <a:rPr sz="1500" b="1">
+                <a:solidFill>
+                  <a:srgbClr val="1B4332"/>
+                </a:solidFill>
+                <a:latin typeface="Calibri"/>
+              </a:rPr>
+              <a:t>Doble codificación — κ de Cohen 0,635</a:t>
+            </a:r>
+          </a:p>
+        </p:txBody>
+      </p:sp>
+      <p:sp>
+        <p:nvSpPr>
+          <p:cNvPr id="7" name="TextBox 6"/>
+          <p:cNvSpPr txBox="1"/>
+          <p:nvPr/>
+        </p:nvSpPr>
+        <p:spPr>
+          <a:xfrm>
+            <a:off x="731520" y="2999232"/>
+            <a:ext cx="10698480" cy="640080"/>
+          </a:xfrm>
+          <a:prstGeom prst="rect">
+            <a:avLst/>
+          </a:prstGeom>
+          <a:noFill/>
+        </p:spPr>
+        <p:txBody>
+          <a:bodyPr wrap="square">
+            <a:spAutoFit/>
+          </a:bodyPr>
+          <a:lstStyle/>
+          <a:p>
+            <a:r>
+              <a:rPr sz="1300" b="0">
+                <a:solidFill>
+                  <a:srgbClr val="6B7A72"/>
+                </a:solidFill>
+                <a:latin typeface="Calibri"/>
+              </a:rPr>
+              <a:t>Dos integrantes codificaron por separado el mismo subconjunto. IC95 % [0,371 · 0,847]: acuerdo sustancial en la escala de Landis y Koch.</a:t>
+            </a:r>
+          </a:p>
+        </p:txBody>
+      </p:sp>
+      <p:sp>
+        <p:nvSpPr>
+          <p:cNvPr id="8" name="TextBox 7"/>
+          <p:cNvSpPr txBox="1"/>
+          <p:nvPr/>
+        </p:nvSpPr>
+        <p:spPr>
+          <a:xfrm>
+            <a:off x="731520" y="3703320"/>
+            <a:ext cx="10698480" cy="320040"/>
+          </a:xfrm>
+          <a:prstGeom prst="rect">
+            <a:avLst/>
+          </a:prstGeom>
+          <a:noFill/>
+        </p:spPr>
+        <p:txBody>
+          <a:bodyPr wrap="square">
+            <a:spAutoFit/>
+          </a:bodyPr>
+          <a:lstStyle/>
+          <a:p>
+            <a:r>
+              <a:rPr sz="1500" b="1">
+                <a:solidFill>
+                  <a:srgbClr val="1B4332"/>
+                </a:solidFill>
+                <a:latin typeface="Calibri"/>
+              </a:rPr>
+              <a:t>Validación — 9 walkthroughs, 2 con usuario técnico</a:t>
+            </a:r>
+          </a:p>
+        </p:txBody>
+      </p:sp>
+      <p:sp>
+        <p:nvSpPr>
+          <p:cNvPr id="9" name="TextBox 8"/>
+          <p:cNvSpPr txBox="1"/>
+          <p:nvPr/>
+        </p:nvSpPr>
+        <p:spPr>
+          <a:xfrm>
+            <a:off x="731520" y="4050791"/>
+            <a:ext cx="10698480" cy="640080"/>
+          </a:xfrm>
+          <a:prstGeom prst="rect">
+            <a:avLst/>
+          </a:prstGeom>
+          <a:noFill/>
+        </p:spPr>
+        <p:txBody>
+          <a:bodyPr wrap="square">
+            <a:spAutoFit/>
+          </a:bodyPr>
+          <a:lstStyle/>
+          <a:p>
+            <a:r>
+              <a:rPr sz="1300" b="0">
+                <a:solidFill>
+                  <a:srgbClr val="6B7A72"/>
+                </a:solidFill>
+                <a:latin typeface="Calibri"/>
+              </a:rPr>
+              <a:t>Notas de campo manuscritas y contemporáneas en las seis últimas; reconstruidas y declaradas como tales en las seis de observación de entorno.</a:t>
+            </a:r>
+          </a:p>
+        </p:txBody>
+      </p:sp>
+      <p:sp>
+        <p:nvSpPr>
+          <p:cNvPr id="10" name="TextBox 9"/>
+          <p:cNvSpPr txBox="1"/>
+          <p:nvPr/>
+        </p:nvSpPr>
+        <p:spPr>
+          <a:xfrm>
+            <a:off x="914400" y="5074920"/>
+            <a:ext cx="10332720" cy="914400"/>
+          </a:xfrm>
+          <a:prstGeom prst="rect">
+            <a:avLst/>
+          </a:prstGeom>
+          <a:noFill/>
+        </p:spPr>
+        <p:txBody>
+          <a:bodyPr wrap="square">
+            <a:spAutoFit/>
+          </a:bodyPr>
+          <a:lstStyle/>
+          <a:p>
+            <a:r>
+              <a:rPr sz="1500" b="1">
+                <a:solidFill>
+                  <a:srgbClr val="1B4332"/>
+                </a:solidFill>
+                <a:latin typeface="Calibri"/>
+              </a:rPr>
+              <a:t>Lo que falta se dice en el propio documento. Una limitación declarada es evidencia; una limitación callada es un hallazgo del tribunal.</a:t>
+            </a:r>
+          </a:p>
+        </p:txBody>
+      </p:sp>
+      <p:sp>
+        <p:nvSpPr>
+          <p:cNvPr id="11" name="TextBox 10"/>
+          <p:cNvSpPr txBox="1"/>
+          <p:nvPr/>
+        </p:nvSpPr>
+        <p:spPr>
+          <a:xfrm>
+            <a:off x="457200" y="6492240"/>
+            <a:ext cx="7315200" cy="274320"/>
+          </a:xfrm>
+          <a:prstGeom prst="rect">
+            <a:avLst/>
+          </a:prstGeom>
+          <a:noFill/>
+        </p:spPr>
+        <p:txBody>
+          <a:bodyPr wrap="square">
+            <a:spAutoFit/>
+          </a:bodyPr>
+          <a:lstStyle/>
+          <a:p>
+            <a:r>
+              <a:rPr sz="1000" b="0">
+                <a:solidFill>
+                  <a:srgbClr val="8A9A93"/>
+                </a:solidFill>
+                <a:latin typeface="Calibri"/>
+              </a:rPr>
+              <a:t>SIGA · Equipo FGMMN · Entrega 4 (2B)</a:t>
+            </a:r>
+          </a:p>
+        </p:txBody>
+      </p:sp>
+      <p:sp>
+        <p:nvSpPr>
+          <p:cNvPr id="12" name="TextBox 11"/>
+          <p:cNvSpPr txBox="1"/>
+          <p:nvPr/>
+        </p:nvSpPr>
+        <p:spPr>
+          <a:xfrm>
+            <a:off x="11247120" y="6492240"/>
+            <a:ext cx="457200" cy="274320"/>
+          </a:xfrm>
+          <a:prstGeom prst="rect">
+            <a:avLst/>
+          </a:prstGeom>
+          <a:noFill/>
+        </p:spPr>
+        <p:txBody>
+          <a:bodyPr wrap="square">
+            <a:spAutoFit/>
+          </a:bodyPr>
+          <a:lstStyle/>
+          <a:p>
+            <a:r>
+              <a:rPr sz="1000" b="0">
+                <a:solidFill>
+                  <a:srgbClr val="8A9A93"/>
+                </a:solidFill>
+                <a:latin typeface="Calibri"/>
+              </a:rPr>
+              <a:t>13</a:t>
+            </a:r>
+          </a:p>
+        </p:txBody>
+      </p:sp>
+    </p:spTree>
+  </p:cSld>
+  <p:clrMapOvr>
+    <a:masterClrMapping/>
+  </p:clrMapOvr>
+</p:sld>
+</file>
+
+<file path=ppt/slides/slide14.xml><?xml version="1.0" encoding="utf-8"?>
 <p:sld xmlns:a="http://schemas.openxmlformats.org/drawingml/2006/main" xmlns:r="http://schemas.openxmlformats.org/officeDocument/2006/relationships" xmlns:p="http://schemas.openxmlformats.org/presentationml/2006/main">
   <p:cSld name="Slide 12">
     <p:bg>
@@ -2671,7 +3850,7 @@
                 <a:ea typeface="Cambria" pitchFamily="34" charset="-122"/>
                 <a:cs typeface="Cambria" pitchFamily="34" charset="-120"/>
               </a:rPr>
-              <a:t>Dos integrantes, veinticinco minutos repartidos</a:t>
+              <a:t>Tres integrantes, veinticinco minutos repartidos</a:t>
             </a:r>
             <a:endParaRPr lang="en-US" sz="3200" dirty="0"/>
           </a:p>
@@ -2807,7 +3986,7 @@
                 <a:ea typeface="Calibri" pitchFamily="34" charset="-122"/>
                 <a:cs typeface="Calibri" pitchFamily="34" charset="-120"/>
               </a:rPr>
-              <a:t>13 min</a:t>
+              <a:t>10 min</a:t>
             </a:r>
             <a:endParaRPr lang="en-US" sz="1300" dirty="0"/>
           </a:p>
@@ -2861,7 +4040,7 @@
         <p:spPr>
           <a:xfrm>
             <a:off x="4023360" y="2478024"/>
-            <a:ext cx="6217920" cy="310896"/>
+            <a:ext cx="9793224" cy="310896"/>
           </a:xfrm>
           <a:prstGeom prst="roundRect">
             <a:avLst>
@@ -2883,14 +4062,14 @@
       </p:sp>
       <p:sp>
         <p:nvSpPr>
-          <p:cNvPr id="10" name="Shape 8"/>
+          <p:cNvPr id="9" name="Shape 7"/>
           <p:cNvSpPr/>
           <p:nvPr/>
         </p:nvSpPr>
         <p:spPr>
           <a:xfrm>
-            <a:off x="4023360" y="2478024"/>
-            <a:ext cx="5739618" cy="310896"/>
+            <a:off x="4023360" y="3191256"/>
+            <a:ext cx="6528816" cy="310896"/>
           </a:xfrm>
           <a:prstGeom prst="roundRect">
             <a:avLst>
@@ -2898,6 +4077,64 @@
             </a:avLst>
           </a:prstGeom>
           <a:solidFill>
+            <a:srgbClr val="E4E9E6"/>
+          </a:solidFill>
+          <a:ln/>
+        </p:spPr>
+        <p:txBody>
+          <a:bodyPr/>
+          <a:lstStyle/>
+          <a:p>
+            <a:endParaRPr/>
+          </a:p>
+        </p:txBody>
+      </p:sp>
+      <p:sp>
+        <p:nvSpPr>
+          <p:cNvPr id="10" name="Shape 8"/>
+          <p:cNvSpPr/>
+          <p:nvPr/>
+        </p:nvSpPr>
+        <p:spPr>
+          <a:xfrm>
+            <a:off x="4023360" y="2478024"/>
+            <a:ext cx="9793224" cy="310896"/>
+          </a:xfrm>
+          <a:prstGeom prst="roundRect">
+            <a:avLst>
+              <a:gd name="adj" fmla="val 11765"/>
+            </a:avLst>
+          </a:prstGeom>
+          <a:solidFill>
+            <a:srgbClr val="1B4332"/>
+          </a:solidFill>
+          <a:ln/>
+        </p:spPr>
+        <p:txBody>
+          <a:bodyPr/>
+          <a:lstStyle/>
+          <a:p>
+            <a:endParaRPr/>
+          </a:p>
+        </p:txBody>
+      </p:sp>
+      <p:sp>
+        <p:nvSpPr>
+          <p:cNvPr id="10" name="Shape 8"/>
+          <p:cNvSpPr/>
+          <p:nvPr/>
+        </p:nvSpPr>
+        <p:spPr>
+          <a:xfrm>
+            <a:off x="4023360" y="3191256"/>
+            <a:ext cx="6528816" cy="310896"/>
+          </a:xfrm>
+          <a:prstGeom prst="roundRect">
+            <a:avLst>
+              <a:gd name="adj" fmla="val 11765"/>
+            </a:avLst>
+          </a:prstGeom>
+          <a:solidFill>
             <a:srgbClr val="1B4332"/>
           </a:solidFill>
           <a:ln/>
@@ -2943,7 +4180,7 @@
                 <a:ea typeface="Calibri" pitchFamily="34" charset="-122"/>
                 <a:cs typeface="Calibri" pitchFamily="34" charset="-120"/>
               </a:rPr>
-              <a:t>12 min</a:t>
+              <a:t>9 min</a:t>
             </a:r>
             <a:endParaRPr lang="en-US" sz="1300" dirty="0"/>
           </a:p>
@@ -2958,7 +4195,7 @@
         <p:spPr>
           <a:xfrm>
             <a:off x="5936566" y="1600200"/>
-            <a:ext cx="0" cy="1417320"/>
+            <a:ext cx="0" cy="2103120"/>
           </a:xfrm>
           <a:prstGeom prst="line">
             <a:avLst/>
@@ -2987,7 +4224,7 @@
         </p:nvSpPr>
         <p:spPr>
           <a:xfrm>
-            <a:off x="5387926" y="3108960"/>
+            <a:off x="5387926" y="3611880"/>
             <a:ext cx="1280160" cy="274320"/>
           </a:xfrm>
           <a:prstGeom prst="rect">
@@ -3080,7 +4317,7 @@
                 <a:ea typeface="Calibri" pitchFamily="34" charset="-122"/>
                 <a:cs typeface="Calibri" pitchFamily="34" charset="-120"/>
               </a:rPr>
-              <a:t>La guía supone equipos de tres a cuatro integrantes y exige al menos cuatro minutos hablados por persona. Este equipo son dos, y cada uno habla muy por encima de ese mínimo. El reparto es de locución: la defensa se rindió de forma individual y cada integrante responde por el proyecto entero.</a:t>
+              <a:t>Los tres superan el mínimo de cuatro minutos por integrante que fija la guía. El reparto sigue la contribución real que declara la matriz de aporte individual.</a:t>
             </a:r>
             <a:endParaRPr lang="en-US" sz="1250" dirty="0"/>
           </a:p>
@@ -3158,9 +4395,77 @@
                 <a:ea typeface="Calibri" pitchFamily="34" charset="-122"/>
                 <a:cs typeface="Calibri" pitchFamily="34" charset="-120"/>
               </a:rPr>
-              <a:t>11</a:t>
+              <a:t>14</a:t>
             </a:r>
             <a:endParaRPr lang="en-US" sz="1000" dirty="0"/>
+          </a:p>
+        </p:txBody>
+      </p:sp>
+      <p:sp>
+        <p:nvSpPr>
+          <p:cNvPr id="26" name="TextBox 25"/>
+          <p:cNvSpPr txBox="1"/>
+          <p:nvPr/>
+        </p:nvSpPr>
+        <p:spPr>
+          <a:xfrm>
+            <a:off x="636422" y="3090672"/>
+            <a:ext cx="3200400" cy="457200"/>
+          </a:xfrm>
+          <a:prstGeom prst="rect">
+            <a:avLst/>
+          </a:prstGeom>
+          <a:noFill/>
+        </p:spPr>
+        <p:txBody>
+          <a:bodyPr wrap="square">
+            <a:spAutoFit/>
+          </a:bodyPr>
+          <a:lstStyle/>
+          <a:p>
+            <a:r>
+              <a:rPr sz="1350">
+                <a:solidFill>
+                  <a:srgbClr val="1B4332"/>
+                </a:solidFill>
+                <a:latin typeface="Calibri"/>
+              </a:rPr>
+              <a:t>Cedeño Ávila, Winston Damián</a:t>
+            </a:r>
+          </a:p>
+        </p:txBody>
+      </p:sp>
+      <p:sp>
+        <p:nvSpPr>
+          <p:cNvPr id="27" name="TextBox 26"/>
+          <p:cNvSpPr txBox="1"/>
+          <p:nvPr/>
+        </p:nvSpPr>
+        <p:spPr>
+          <a:xfrm>
+            <a:off x="10378440" y="3090672"/>
+            <a:ext cx="914400" cy="457200"/>
+          </a:xfrm>
+          <a:prstGeom prst="rect">
+            <a:avLst/>
+          </a:prstGeom>
+          <a:noFill/>
+        </p:spPr>
+        <p:txBody>
+          <a:bodyPr wrap="square">
+            <a:spAutoFit/>
+          </a:bodyPr>
+          <a:lstStyle/>
+          <a:p>
+            <a:r>
+              <a:rPr sz="1300" b="1">
+                <a:solidFill>
+                  <a:srgbClr val="1B4332"/>
+                </a:solidFill>
+                <a:latin typeface="Calibri"/>
+              </a:rPr>
+              <a:t>6 min</a:t>
+            </a:r>
           </a:p>
         </p:txBody>
       </p:sp>
@@ -3172,7 +4477,7 @@
 </p:sld>
 </file>
 
-<file path=ppt/slides/slide12.xml><?xml version="1.0" encoding="utf-8"?>
+<file path=ppt/slides/slide15.xml><?xml version="1.0" encoding="utf-8"?>
 <p:sld xmlns:a="http://schemas.openxmlformats.org/drawingml/2006/main" xmlns:r="http://schemas.openxmlformats.org/officeDocument/2006/relationships" xmlns:p="http://schemas.openxmlformats.org/presentationml/2006/main">
   <p:cSld name="Slide 13">
     <p:bg>
@@ -3499,7 +4804,7 @@
                 <a:ea typeface="Calibri" pitchFamily="34" charset="-122"/>
                 <a:cs typeface="Calibri" pitchFamily="34" charset="-120"/>
               </a:rPr>
-              <a:t>BLOQUE 1 · 3 MIN</a:t>
+              <a:t>BLOQUE 1 · 2 MIN</a:t>
             </a:r>
             <a:endParaRPr lang="en-US" sz="1200" dirty="0"/>
           </a:p>
@@ -5192,7 +6497,7 @@
                 <a:ea typeface="Calibri" pitchFamily="34" charset="-122"/>
                 <a:cs typeface="Calibri" pitchFamily="34" charset="-120"/>
               </a:rPr>
-              <a:t>BLOQUE 3 · 4 MIN</a:t>
+              <a:t>BLOQUE 3 · 3 MIN</a:t>
             </a:r>
             <a:endParaRPr lang="en-US" sz="1200" dirty="0"/>
           </a:p>
@@ -7308,7 +8613,7 @@
                 <a:ea typeface="Calibri" pitchFamily="34" charset="-122"/>
                 <a:cs typeface="Calibri" pitchFamily="34" charset="-120"/>
               </a:rPr>
-              <a:t>BLOQUE 5 · 4 MIN</a:t>
+              <a:t>BLOQUE 5 · 3 MIN</a:t>
             </a:r>
             <a:endParaRPr lang="en-US" sz="1200" dirty="0"/>
           </a:p>

</xml_diff>

<commit_message>
fix(defensa): la diapositiva 13 seguia contando nueve sesiones y dos tecnicas
Con WT-10 son diez sesiones de validacion y tres con usuario tecnico. Era la
ultima cifra de las diapositivas sin actualizar: el resto ya declaraba las
dieciseis entrevistas codificadas. Los dos 34 de las diapositivas 7 y 9 son el
n del calculo de potencia y se dejan como estan.

PDF reexportado desde el pptx.
</commit_message>
<xml_diff>
--- a/08_Defensa/presentacion.pptx
+++ b/08_Defensa/presentacion.pptx
@@ -3434,7 +3434,7 @@
                 </a:solidFill>
                 <a:latin typeface="Cambria"/>
               </a:rPr>
-              <a:t>N = 16 entrevistas, 9 sesiones de validación, 12 notas de campo</a:t>
+              <a:t>N = 16 entrevistas, 10 sesiones de validación, 12 notas de campo</a:t>
             </a:r>
           </a:p>
         </p:txBody>
@@ -3604,7 +3604,7 @@
                 </a:solidFill>
                 <a:latin typeface="Calibri"/>
               </a:rPr>
-              <a:t>Validación — 9 walkthroughs, 2 con usuario técnico</a:t>
+              <a:t>Validación — 10 walkthroughs, 3 con usuario técnico</a:t>
             </a:r>
           </a:p>
         </p:txBody>

</xml_diff>

<commit_message>
feat(defensa): la diapositiva 9 pasa a ser el paquete de replicacion y el deposito FAIR
Repetia lo que la diapositiva 8 ya dice sobre el alcance del resultado y anadia
el trabajo futuro. Se sustituye por un logro concreto del equipo que no
presentaba ninguna de las quince: el paquete de replicacion, sus tres
identificadores persistentes --- Zenodo con el DOI de la version 2B-1.12.0, OSF
con el protocolo registrado antes de recoger datos, y Software Heritage con el
codigo archivado --- y la autoevaluacion FAIR, 22 de 26 indicadores y un
84,62 %, con Findable en 7 de 7.

Todas las cifras salen de fair_assessment.json y CITATION.cff. La respuesta a la
pregunta de investigacion sigue dicha en la diapositiva 8, de modo que la
defensa contesta a su propia pregunta.

Reescritos tambien la entrada del libreto y las notas del orador.
</commit_message>
<xml_diff>
--- a/08_Defensa/presentacion.pptx
+++ b/08_Defensa/presentacion.pptx
@@ -1244,7 +1244,7 @@
           <a:lstStyle/>
           <a:p>
             <a:r>
-              <a:t>RQ1 queda abierta: no se puede confirmar ni descartar con este tamano de muestra, y no se sobre-interpreta la tendencia favorable al LLM. Trabajo futuro: ampliar el panel a 34 jueces y con evaluadores entrenados; regenerar los dos conjuntos sobre el corpus completo de 16 entrevistas; ampliar la ronda terminal mas alla del perfil docente. Cerrar reafirmando las tres contribuciones.</a:t>
+              <a:t>El paquete de replicacion es un logro verificable y no lo presenta ninguna otra diapositiva. Tres identificadores persistentes: Zenodo con el DOI de la version 2B-1.12.0, OSF con el protocolo registrado antes de recoger datos, y Software Heritage con el codigo archivado. La autoevaluacion FAIR con F-UJI da 22 de 26, 84,62 %, con Findable en 7 de 7. Si preguntan por la respuesta a RQ1, ya se dijo en la diapositiva 8: la tendencia favorable al LLM no se sostiene con este tamano de muestra.</a:t>
             </a:r>
           </a:p>
         </p:txBody>
@@ -9398,7 +9398,7 @@
                 <a:ea typeface="Calibri" pitchFamily="34" charset="-122"/>
                 <a:cs typeface="Calibri" pitchFamily="34" charset="-120"/>
               </a:rPr>
-              <a:t>BLOQUE 6 · 3 MIN</a:t>
+              <a:t>BLOQUE 6 · 3 MIN — PAQUETE DE REPLICACIÓN</a:t>
             </a:r>
             <a:endParaRPr lang="en-US" sz="1200" dirty="0"/>
           </a:p>
@@ -9437,7 +9437,7 @@
                 <a:ea typeface="Cambria" pitchFamily="34" charset="-122"/>
                 <a:cs typeface="Cambria" pitchFamily="34" charset="-120"/>
               </a:rPr>
-              <a:t>RQ1 queda abierta — con honestidad, no con evasión</a:t>
+              <a:t>Cualquiera puede rehacer este estudio sin pedirnos nada</a:t>
             </a:r>
             <a:endParaRPr lang="en-US" sz="3200" dirty="0"/>
           </a:p>
@@ -9505,7 +9505,7 @@
                 <a:ea typeface="Calibri" pitchFamily="34" charset="-122"/>
                 <a:cs typeface="Calibri" pitchFamily="34" charset="-120"/>
               </a:rPr>
-              <a:t>No se puede confirmar ni descartar una diferencia de calidad con el tamaño de muestra actual. Se declara así explícitamente, sin sobre-interpretar la tendencia numérica favorable al LLM.</a:t>
+              <a:t>El paquete publicado lleva los datos crudos, los scripts de análisis y los resultados. Una sola orden regenera las tablas y las figuras del manuscrito a partir de los datos.</a:t>
             </a:r>
             <a:endParaRPr lang="en-US" sz="1450" dirty="0"/>
           </a:p>
@@ -9544,7 +9544,7 @@
                 <a:ea typeface="Calibri" pitchFamily="34" charset="-122"/>
                 <a:cs typeface="Calibri" pitchFamily="34" charset="-120"/>
               </a:rPr>
-              <a:t>Trabajo futuro concreto</a:t>
+              <a:t>Tres identificadores persistentes, los tres verificados</a:t>
             </a:r>
             <a:endParaRPr lang="en-US" sz="1500" dirty="0"/>
           </a:p>
@@ -9610,7 +9610,7 @@
                 <a:ea typeface="Calibri" pitchFamily="34" charset="-122"/>
                 <a:cs typeface="Calibri" pitchFamily="34" charset="-120"/>
               </a:rPr>
-              <a:t>Ampliar el panel de jueces a 34, el n requerido por el cálculo de potencia.</a:t>
+              <a:t>Zenodo — DOI 10.5281/zenodo.22663649, versión 2B-1.12.0 del paquete de datos, bajo licencia CC BY 4.0.</a:t>
             </a:r>
             <a:endParaRPr lang="en-US" sz="1400" dirty="0"/>
           </a:p>
@@ -9676,7 +9676,7 @@
                 <a:ea typeface="Calibri" pitchFamily="34" charset="-122"/>
                 <a:cs typeface="Calibri" pitchFamily="34" charset="-120"/>
               </a:rPr>
-              <a:t>Re-generar los dos conjuntos sobre el corpus completo de 16 entrevistas.</a:t>
+              <a:t>OSF — DOI 10.17605/OSF.IO/7PQ3H, el protocolo registrado el 2 de agosto, antes de recoger datos y con sello temporal externo.</a:t>
             </a:r>
             <a:endParaRPr lang="en-US" sz="1400" dirty="0"/>
           </a:p>
@@ -9742,7 +9742,7 @@
                 <a:ea typeface="Calibri" pitchFamily="34" charset="-122"/>
                 <a:cs typeface="Calibri" pitchFamily="34" charset="-120"/>
               </a:rPr>
-              <a:t>Ampliar la ronda terminal más allá del perfil docente.</a:t>
+              <a:t>Software Heritage — el código archivado con su SWHID, swh:1:snp:861295fead33417e3efc2753fd4a34897014a891.</a:t>
             </a:r>
             <a:endParaRPr lang="en-US" sz="1400" dirty="0"/>
           </a:p>
@@ -9810,7 +9810,7 @@
                 <a:ea typeface="Cambria" pitchFamily="34" charset="-122"/>
                 <a:cs typeface="Cambria" pitchFamily="34" charset="-120"/>
               </a:rPr>
-              <a:t>Las 3 contribuciones del bloque 1 se sostienen con la evidencia ya mostrada.</a:t>
+              <a:t>Autoevaluación FAIR con la herramienta F-UJI: 22 de 26 indicadores, un 84,62 %. Localizable, 7 de 7.</a:t>
             </a:r>
             <a:endParaRPr lang="en-US" sz="1600" dirty="0"/>
           </a:p>

</xml_diff>